<commit_message>
Rebrand UI text and reorganize documentation
Update UI labels and tidy documentation structure: change NavBar subtitle from "SOC Engine" to "SIRA" and expand footer to "Security Incident Response Assistant Dashboard". Move snort-setup.md and winlogbeat-setup.md into Documentation/setup-guides/ for better organization, add a new Documentation/report.docx, and replace Designs/poster.pptx (binary update).
</commit_message>
<xml_diff>
--- a/Designs/poster.pptx
+++ b/Designs/poster.pptx
@@ -243,7 +243,7 @@
           <a:p>
             <a:fld id="{AB737988-853F-4A76-B621-D8C2E532EA24}" type="datetimeFigureOut">
               <a:rPr lang="en-GB" smtClean="0"/>
-              <a:t>16/03/2026</a:t>
+              <a:t>17/03/2026</a:t>
             </a:fld>
             <a:endParaRPr lang="en-GB"/>
           </a:p>
@@ -413,7 +413,7 @@
           <a:p>
             <a:fld id="{AB737988-853F-4A76-B621-D8C2E532EA24}" type="datetimeFigureOut">
               <a:rPr lang="en-GB" smtClean="0"/>
-              <a:t>16/03/2026</a:t>
+              <a:t>17/03/2026</a:t>
             </a:fld>
             <a:endParaRPr lang="en-GB"/>
           </a:p>
@@ -593,7 +593,7 @@
           <a:p>
             <a:fld id="{AB737988-853F-4A76-B621-D8C2E532EA24}" type="datetimeFigureOut">
               <a:rPr lang="en-GB" smtClean="0"/>
-              <a:t>16/03/2026</a:t>
+              <a:t>17/03/2026</a:t>
             </a:fld>
             <a:endParaRPr lang="en-GB"/>
           </a:p>
@@ -763,7 +763,7 @@
           <a:p>
             <a:fld id="{AB737988-853F-4A76-B621-D8C2E532EA24}" type="datetimeFigureOut">
               <a:rPr lang="en-GB" smtClean="0"/>
-              <a:t>16/03/2026</a:t>
+              <a:t>17/03/2026</a:t>
             </a:fld>
             <a:endParaRPr lang="en-GB"/>
           </a:p>
@@ -1009,7 +1009,7 @@
           <a:p>
             <a:fld id="{AB737988-853F-4A76-B621-D8C2E532EA24}" type="datetimeFigureOut">
               <a:rPr lang="en-GB" smtClean="0"/>
-              <a:t>16/03/2026</a:t>
+              <a:t>17/03/2026</a:t>
             </a:fld>
             <a:endParaRPr lang="en-GB"/>
           </a:p>
@@ -1241,7 +1241,7 @@
           <a:p>
             <a:fld id="{AB737988-853F-4A76-B621-D8C2E532EA24}" type="datetimeFigureOut">
               <a:rPr lang="en-GB" smtClean="0"/>
-              <a:t>16/03/2026</a:t>
+              <a:t>17/03/2026</a:t>
             </a:fld>
             <a:endParaRPr lang="en-GB"/>
           </a:p>
@@ -1608,7 +1608,7 @@
           <a:p>
             <a:fld id="{AB737988-853F-4A76-B621-D8C2E532EA24}" type="datetimeFigureOut">
               <a:rPr lang="en-GB" smtClean="0"/>
-              <a:t>16/03/2026</a:t>
+              <a:t>17/03/2026</a:t>
             </a:fld>
             <a:endParaRPr lang="en-GB"/>
           </a:p>
@@ -1726,7 +1726,7 @@
           <a:p>
             <a:fld id="{AB737988-853F-4A76-B621-D8C2E532EA24}" type="datetimeFigureOut">
               <a:rPr lang="en-GB" smtClean="0"/>
-              <a:t>16/03/2026</a:t>
+              <a:t>17/03/2026</a:t>
             </a:fld>
             <a:endParaRPr lang="en-GB"/>
           </a:p>
@@ -1821,7 +1821,7 @@
           <a:p>
             <a:fld id="{AB737988-853F-4A76-B621-D8C2E532EA24}" type="datetimeFigureOut">
               <a:rPr lang="en-GB" smtClean="0"/>
-              <a:t>16/03/2026</a:t>
+              <a:t>17/03/2026</a:t>
             </a:fld>
             <a:endParaRPr lang="en-GB"/>
           </a:p>
@@ -2098,7 +2098,7 @@
           <a:p>
             <a:fld id="{AB737988-853F-4A76-B621-D8C2E532EA24}" type="datetimeFigureOut">
               <a:rPr lang="en-GB" smtClean="0"/>
-              <a:t>16/03/2026</a:t>
+              <a:t>17/03/2026</a:t>
             </a:fld>
             <a:endParaRPr lang="en-GB"/>
           </a:p>
@@ -2355,7 +2355,7 @@
           <a:p>
             <a:fld id="{AB737988-853F-4A76-B621-D8C2E532EA24}" type="datetimeFigureOut">
               <a:rPr lang="en-GB" smtClean="0"/>
-              <a:t>16/03/2026</a:t>
+              <a:t>17/03/2026</a:t>
             </a:fld>
             <a:endParaRPr lang="en-GB"/>
           </a:p>
@@ -2568,7 +2568,7 @@
           <a:p>
             <a:fld id="{AB737988-853F-4A76-B621-D8C2E532EA24}" type="datetimeFigureOut">
               <a:rPr lang="en-GB" smtClean="0"/>
-              <a:t>16/03/2026</a:t>
+              <a:t>17/03/2026</a:t>
             </a:fld>
             <a:endParaRPr lang="en-GB"/>
           </a:p>
@@ -5584,7 +5584,7 @@
         </p:blipFill>
         <p:spPr>
           <a:xfrm>
-            <a:off x="10801579" y="16712799"/>
+            <a:off x="10770603" y="16515706"/>
             <a:ext cx="626793" cy="626795"/>
           </a:xfrm>
           <a:prstGeom prst="rect">
@@ -5606,8 +5606,8 @@
         </p:nvSpPr>
         <p:spPr>
           <a:xfrm>
-            <a:off x="11303698" y="16680959"/>
-            <a:ext cx="4961879" cy="1200329"/>
+            <a:off x="11303698" y="16509369"/>
+            <a:ext cx="3955906" cy="1754326"/>
           </a:xfrm>
           <a:prstGeom prst="rect">
             <a:avLst/>
@@ -5626,7 +5626,7 @@
                   <a:schemeClr val="bg1"/>
                 </a:solidFill>
               </a:rPr>
-              <a:t>Security:</a:t>
+              <a:t>Security: </a:t>
             </a:r>
             <a:r>
               <a:rPr lang="en-GB" sz="3600" dirty="0">
@@ -5634,9 +5634,9 @@
                   <a:schemeClr val="bg1"/>
                 </a:solidFill>
               </a:rPr>
-              <a:t> AES-256 payload encryption.</a:t>
-            </a:r>
-            <a:endParaRPr lang="en-GB" sz="3600" b="1" dirty="0">
+              <a:t>Fernet AES Payload Encryption</a:t>
+            </a:r>
+            <a:endParaRPr lang="en-GB" sz="3600" dirty="0">
               <a:solidFill>
                 <a:schemeClr val="bg1"/>
               </a:solidFill>

</xml_diff>